<commit_message>
Add screenshot slides to presentation (8 slides total)
</commit_message>
<xml_diff>
--- a/Student_Grade_Calculator_Presentation.pptx
+++ b/Student_Grade_Calculator_Presentation.pptx
@@ -10,6 +10,9 @@
     <p:sldId id="258" r:id="rId9"/>
     <p:sldId id="259" r:id="rId10"/>
     <p:sldId id="260" r:id="rId11"/>
+    <p:sldId id="261" r:id="rId12"/>
+    <p:sldId id="262" r:id="rId13"/>
+    <p:sldId id="263" r:id="rId14"/>
   </p:sldIdLst>
   <p:sldSz cx="12191695" cy="6858000" type="screen4x3"/>
   <p:notesSz cx="6858000" cy="9144000"/>
@@ -4927,6 +4930,273 @@
           </a:p>
         </p:txBody>
       </p:sp>
+    </p:spTree>
+  </p:cSld>
+  <p:clrMapOvr>
+    <a:masterClrMapping/>
+  </p:clrMapOvr>
+</p:sld>
+</file>
+
+<file path=ppt/slides/slide6.xml><?xml version="1.0" encoding="utf-8"?>
+<p:sld xmlns:a="http://schemas.openxmlformats.org/drawingml/2006/main" xmlns:p="http://schemas.openxmlformats.org/presentationml/2006/main" xmlns:r="http://schemas.openxmlformats.org/officeDocument/2006/relationships">
+  <p:cSld>
+    <p:spTree>
+      <p:nvGrpSpPr>
+        <p:cNvPr id="1" name=""/>
+        <p:cNvGrpSpPr/>
+        <p:nvPr/>
+      </p:nvGrpSpPr>
+      <p:grpSpPr/>
+      <p:sp>
+        <p:nvSpPr>
+          <p:cNvPr id="2" name="TextBox 1"/>
+          <p:cNvSpPr txBox="1"/>
+          <p:nvPr/>
+        </p:nvSpPr>
+        <p:spPr>
+          <a:xfrm>
+            <a:off x="731520" y="365760"/>
+            <a:ext cx="10698480" cy="1005840"/>
+          </a:xfrm>
+          <a:prstGeom prst="rect">
+            <a:avLst/>
+          </a:prstGeom>
+          <a:noFill/>
+        </p:spPr>
+        <p:txBody>
+          <a:bodyPr wrap="square" lIns="0" tIns="0" rIns="0" bIns="0">
+            <a:spAutoFit/>
+          </a:bodyPr>
+          <a:lstStyle/>
+          <a:p>
+            <a:pPr>
+              <a:defRPr sz="2400" b="1">
+                <a:solidFill>
+                  <a:srgbClr val="0F172A"/>
+                </a:solidFill>
+              </a:defRPr>
+            </a:pPr>
+            <a:r>
+              <a:t>5. Screenshot: Grade Calculator View</a:t>
+            </a:r>
+          </a:p>
+          <a:p>
+            <a:pPr>
+              <a:defRPr sz="1300">
+                <a:solidFill>
+                  <a:srgbClr val="64748B"/>
+                </a:solidFill>
+              </a:defRPr>
+            </a:pPr>
+            <a:r>
+              <a:t>Real-time calculation of total, average, letter grade, and pass/fail status</a:t>
+            </a:r>
+          </a:p>
+        </p:txBody>
+      </p:sp>
+      <p:pic>
+        <p:nvPicPr>
+          <p:cNvPr id="3" name="Picture 2" descr="grade-calculator.png"/>
+          <p:cNvPicPr>
+            <a:picLocks noChangeAspect="1"/>
+          </p:cNvPicPr>
+          <p:nvPr/>
+        </p:nvPicPr>
+        <p:blipFill>
+          <a:blip r:embed="rId2"/>
+          <a:stretch>
+            <a:fillRect/>
+          </a:stretch>
+        </p:blipFill>
+        <p:spPr>
+          <a:xfrm>
+            <a:off x="1294790" y="1463040"/>
+            <a:ext cx="9601200" cy="4937760"/>
+          </a:xfrm>
+          <a:prstGeom prst="rect">
+            <a:avLst/>
+          </a:prstGeom>
+        </p:spPr>
+      </p:pic>
+    </p:spTree>
+  </p:cSld>
+  <p:clrMapOvr>
+    <a:masterClrMapping/>
+  </p:clrMapOvr>
+</p:sld>
+</file>
+
+<file path=ppt/slides/slide7.xml><?xml version="1.0" encoding="utf-8"?>
+<p:sld xmlns:a="http://schemas.openxmlformats.org/drawingml/2006/main" xmlns:p="http://schemas.openxmlformats.org/presentationml/2006/main" xmlns:r="http://schemas.openxmlformats.org/officeDocument/2006/relationships">
+  <p:cSld>
+    <p:spTree>
+      <p:nvGrpSpPr>
+        <p:cNvPr id="1" name=""/>
+        <p:cNvGrpSpPr/>
+        <p:nvPr/>
+      </p:nvGrpSpPr>
+      <p:grpSpPr/>
+      <p:sp>
+        <p:nvSpPr>
+          <p:cNvPr id="2" name="TextBox 1"/>
+          <p:cNvSpPr txBox="1"/>
+          <p:nvPr/>
+        </p:nvSpPr>
+        <p:spPr>
+          <a:xfrm>
+            <a:off x="731520" y="365760"/>
+            <a:ext cx="10698480" cy="1005840"/>
+          </a:xfrm>
+          <a:prstGeom prst="rect">
+            <a:avLst/>
+          </a:prstGeom>
+          <a:noFill/>
+        </p:spPr>
+        <p:txBody>
+          <a:bodyPr wrap="square" lIns="0" tIns="0" rIns="0" bIns="0">
+            <a:spAutoFit/>
+          </a:bodyPr>
+          <a:lstStyle/>
+          <a:p>
+            <a:pPr>
+              <a:defRPr sz="2400" b="1">
+                <a:solidFill>
+                  <a:srgbClr val="0F172A"/>
+                </a:solidFill>
+              </a:defRPr>
+            </a:pPr>
+            <a:r>
+              <a:t>6. Screenshot: Student Records Directory</a:t>
+            </a:r>
+          </a:p>
+          <a:p>
+            <a:pPr>
+              <a:defRPr sz="1300">
+                <a:solidFill>
+                  <a:srgbClr val="64748B"/>
+                </a:solidFill>
+              </a:defRPr>
+            </a:pPr>
+            <a:r>
+              <a:t>Interactive table with search by name/roll no, filtering, edit and delete</a:t>
+            </a:r>
+          </a:p>
+        </p:txBody>
+      </p:sp>
+      <p:pic>
+        <p:nvPicPr>
+          <p:cNvPr id="3" name="Picture 2" descr="student-records.png"/>
+          <p:cNvPicPr>
+            <a:picLocks noChangeAspect="1"/>
+          </p:cNvPicPr>
+          <p:nvPr/>
+        </p:nvPicPr>
+        <p:blipFill>
+          <a:blip r:embed="rId2"/>
+          <a:stretch>
+            <a:fillRect/>
+          </a:stretch>
+        </p:blipFill>
+        <p:spPr>
+          <a:xfrm>
+            <a:off x="1294790" y="1463040"/>
+            <a:ext cx="9601200" cy="4937760"/>
+          </a:xfrm>
+          <a:prstGeom prst="rect">
+            <a:avLst/>
+          </a:prstGeom>
+        </p:spPr>
+      </p:pic>
+    </p:spTree>
+  </p:cSld>
+  <p:clrMapOvr>
+    <a:masterClrMapping/>
+  </p:clrMapOvr>
+</p:sld>
+</file>
+
+<file path=ppt/slides/slide8.xml><?xml version="1.0" encoding="utf-8"?>
+<p:sld xmlns:a="http://schemas.openxmlformats.org/drawingml/2006/main" xmlns:p="http://schemas.openxmlformats.org/presentationml/2006/main" xmlns:r="http://schemas.openxmlformats.org/officeDocument/2006/relationships">
+  <p:cSld>
+    <p:spTree>
+      <p:nvGrpSpPr>
+        <p:cNvPr id="1" name=""/>
+        <p:cNvGrpSpPr/>
+        <p:nvPr/>
+      </p:nvGrpSpPr>
+      <p:grpSpPr/>
+      <p:sp>
+        <p:nvSpPr>
+          <p:cNvPr id="2" name="TextBox 1"/>
+          <p:cNvSpPr txBox="1"/>
+          <p:nvPr/>
+        </p:nvSpPr>
+        <p:spPr>
+          <a:xfrm>
+            <a:off x="731520" y="365760"/>
+            <a:ext cx="10698480" cy="1005840"/>
+          </a:xfrm>
+          <a:prstGeom prst="rect">
+            <a:avLst/>
+          </a:prstGeom>
+          <a:noFill/>
+        </p:spPr>
+        <p:txBody>
+          <a:bodyPr wrap="square" lIns="0" tIns="0" rIns="0" bIns="0">
+            <a:spAutoFit/>
+          </a:bodyPr>
+          <a:lstStyle/>
+          <a:p>
+            <a:pPr>
+              <a:defRPr sz="2400" b="1">
+                <a:solidFill>
+                  <a:srgbClr val="0F172A"/>
+                </a:solidFill>
+              </a:defRPr>
+            </a:pPr>
+            <a:r>
+              <a:t>7. Screenshot: Grading Scheme &amp; Rules</a:t>
+            </a:r>
+          </a:p>
+          <a:p>
+            <a:pPr>
+              <a:defRPr sz="1300">
+                <a:solidFill>
+                  <a:srgbClr val="64748B"/>
+                </a:solidFill>
+              </a:defRPr>
+            </a:pPr>
+            <a:r>
+              <a:t>Reference table showing marks percentage cutoffs, assigned grades, and formulas</a:t>
+            </a:r>
+          </a:p>
+        </p:txBody>
+      </p:sp>
+      <p:pic>
+        <p:nvPicPr>
+          <p:cNvPr id="3" name="Picture 2" descr="grading-scale.png"/>
+          <p:cNvPicPr>
+            <a:picLocks noChangeAspect="1"/>
+          </p:cNvPicPr>
+          <p:nvPr/>
+        </p:nvPicPr>
+        <p:blipFill>
+          <a:blip r:embed="rId2"/>
+          <a:stretch>
+            <a:fillRect/>
+          </a:stretch>
+        </p:blipFill>
+        <p:spPr>
+          <a:xfrm>
+            <a:off x="1294790" y="1463040"/>
+            <a:ext cx="9601200" cy="4937760"/>
+          </a:xfrm>
+          <a:prstGeom prst="rect">
+            <a:avLst/>
+          </a:prstGeom>
+        </p:spPr>
+      </p:pic>
     </p:spTree>
   </p:cSld>
   <p:clrMapOvr>

</xml_diff>

<commit_message>
Add Netlify configuration (netlify.toml, redirects, relative base)
</commit_message>
<xml_diff>
--- a/Student_Grade_Calculator_Presentation.pptx
+++ b/Student_Grade_Calculator_Presentation.pptx
@@ -5,16 +5,16 @@
     <p:sldMasterId id="2147483648" r:id="rId1"/>
   </p:sldMasterIdLst>
   <p:sldIdLst>
-    <p:sldId id="256" r:id="rId7"/>
-    <p:sldId id="257" r:id="rId8"/>
-    <p:sldId id="258" r:id="rId9"/>
-    <p:sldId id="259" r:id="rId10"/>
-    <p:sldId id="260" r:id="rId11"/>
-    <p:sldId id="261" r:id="rId12"/>
-    <p:sldId id="262" r:id="rId13"/>
-    <p:sldId id="263" r:id="rId14"/>
+    <p:sldId id="256" r:id="rId2"/>
+    <p:sldId id="257" r:id="rId3"/>
+    <p:sldId id="258" r:id="rId4"/>
+    <p:sldId id="259" r:id="rId5"/>
+    <p:sldId id="260" r:id="rId6"/>
+    <p:sldId id="261" r:id="rId7"/>
+    <p:sldId id="262" r:id="rId8"/>
+    <p:sldId id="263" r:id="rId9"/>
   </p:sldIdLst>
-  <p:sldSz cx="12191695" cy="6858000" type="screen4x3"/>
+  <p:sldSz cx="12192000" cy="6858000"/>
   <p:notesSz cx="6858000" cy="9144000"/>
   <p:defaultTextStyle>
     <a:defPPr>
@@ -111,6 +111,22 @@
       </a:defRPr>
     </a:lvl9pPr>
   </p:defaultTextStyle>
+  <p:extLst>
+    <p:ext uri="{EFAFB233-063F-42B5-8137-9DF3F51BA10A}">
+      <p15:sldGuideLst xmlns:p15="http://schemas.microsoft.com/office/powerpoint/2012/main">
+        <p15:guide id="1" orient="horz" pos="2160">
+          <p15:clr>
+            <a:srgbClr val="A4A3A4"/>
+          </p15:clr>
+        </p15:guide>
+        <p15:guide id="2" pos="2880">
+          <p15:clr>
+            <a:srgbClr val="A4A3A4"/>
+          </p15:clr>
+        </p15:guide>
+      </p15:sldGuideLst>
+    </p:ext>
+  </p:extLst>
 </p:presentation>
 </file>
 
@@ -152,10 +168,9 @@
           <a:lstStyle/>
           <a:p>
             <a:r>
-              <a:rPr lang="en-US" smtClean="0"/>
+              <a:rPr lang="en-US"/>
               <a:t>Click to edit Master title style</a:t>
             </a:r>
-            <a:endParaRPr lang="en-US"/>
           </a:p>
         </p:txBody>
       </p:sp>
@@ -271,10 +286,9 @@
           </a:lstStyle>
           <a:p>
             <a:r>
-              <a:rPr lang="en-US" smtClean="0"/>
+              <a:rPr lang="en-US"/>
               <a:t>Click to edit Master subtitle style</a:t>
             </a:r>
-            <a:endParaRPr lang="en-US"/>
           </a:p>
         </p:txBody>
       </p:sp>
@@ -295,7 +309,7 @@
           <a:p>
             <a:fld id="{5BCAD085-E8A6-8845-BD4E-CB4CCA059FC4}" type="datetimeFigureOut">
               <a:rPr lang="en-US" smtClean="0"/>
-              <a:t>1/27/13</a:t>
+              <a:t>9/27/2026</a:t>
             </a:fld>
             <a:endParaRPr lang="en-US"/>
           </a:p>
@@ -389,10 +403,9 @@
           <a:lstStyle/>
           <a:p>
             <a:r>
-              <a:rPr lang="en-US" smtClean="0"/>
+              <a:rPr lang="en-US"/>
               <a:t>Click to edit Master title style</a:t>
             </a:r>
-            <a:endParaRPr lang="en-US"/>
           </a:p>
         </p:txBody>
       </p:sp>
@@ -413,38 +426,37 @@
           <a:p>
             <a:pPr lvl="0"/>
             <a:r>
-              <a:rPr lang="en-US" smtClean="0"/>
+              <a:rPr lang="en-US"/>
               <a:t>Click to edit Master text styles</a:t>
             </a:r>
           </a:p>
           <a:p>
             <a:pPr lvl="1"/>
             <a:r>
-              <a:rPr lang="en-US" smtClean="0"/>
+              <a:rPr lang="en-US"/>
               <a:t>Second level</a:t>
             </a:r>
           </a:p>
           <a:p>
             <a:pPr lvl="2"/>
             <a:r>
-              <a:rPr lang="en-US" smtClean="0"/>
+              <a:rPr lang="en-US"/>
               <a:t>Third level</a:t>
             </a:r>
           </a:p>
           <a:p>
             <a:pPr lvl="3"/>
             <a:r>
-              <a:rPr lang="en-US" smtClean="0"/>
+              <a:rPr lang="en-US"/>
               <a:t>Fourth level</a:t>
             </a:r>
           </a:p>
           <a:p>
             <a:pPr lvl="4"/>
             <a:r>
-              <a:rPr lang="en-US" smtClean="0"/>
+              <a:rPr lang="en-US"/>
               <a:t>Fifth level</a:t>
             </a:r>
-            <a:endParaRPr lang="en-US"/>
           </a:p>
         </p:txBody>
       </p:sp>
@@ -465,7 +477,7 @@
           <a:p>
             <a:fld id="{5BCAD085-E8A6-8845-BD4E-CB4CCA059FC4}" type="datetimeFigureOut">
               <a:rPr lang="en-US" smtClean="0"/>
-              <a:t>1/27/13</a:t>
+              <a:t>9/27/2026</a:t>
             </a:fld>
             <a:endParaRPr lang="en-US"/>
           </a:p>
@@ -564,10 +576,9 @@
           <a:lstStyle/>
           <a:p>
             <a:r>
-              <a:rPr lang="en-US" smtClean="0"/>
+              <a:rPr lang="en-US"/>
               <a:t>Click to edit Master title style</a:t>
             </a:r>
-            <a:endParaRPr lang="en-US"/>
           </a:p>
         </p:txBody>
       </p:sp>
@@ -593,38 +604,37 @@
           <a:p>
             <a:pPr lvl="0"/>
             <a:r>
-              <a:rPr lang="en-US" smtClean="0"/>
+              <a:rPr lang="en-US"/>
               <a:t>Click to edit Master text styles</a:t>
             </a:r>
           </a:p>
           <a:p>
             <a:pPr lvl="1"/>
             <a:r>
-              <a:rPr lang="en-US" smtClean="0"/>
+              <a:rPr lang="en-US"/>
               <a:t>Second level</a:t>
             </a:r>
           </a:p>
           <a:p>
             <a:pPr lvl="2"/>
             <a:r>
-              <a:rPr lang="en-US" smtClean="0"/>
+              <a:rPr lang="en-US"/>
               <a:t>Third level</a:t>
             </a:r>
           </a:p>
           <a:p>
             <a:pPr lvl="3"/>
             <a:r>
-              <a:rPr lang="en-US" smtClean="0"/>
+              <a:rPr lang="en-US"/>
               <a:t>Fourth level</a:t>
             </a:r>
           </a:p>
           <a:p>
             <a:pPr lvl="4"/>
             <a:r>
-              <a:rPr lang="en-US" smtClean="0"/>
+              <a:rPr lang="en-US"/>
               <a:t>Fifth level</a:t>
             </a:r>
-            <a:endParaRPr lang="en-US"/>
           </a:p>
         </p:txBody>
       </p:sp>
@@ -645,7 +655,7 @@
           <a:p>
             <a:fld id="{5BCAD085-E8A6-8845-BD4E-CB4CCA059FC4}" type="datetimeFigureOut">
               <a:rPr lang="en-US" smtClean="0"/>
-              <a:t>1/27/13</a:t>
+              <a:t>9/27/2026</a:t>
             </a:fld>
             <a:endParaRPr lang="en-US"/>
           </a:p>
@@ -739,10 +749,9 @@
           <a:lstStyle/>
           <a:p>
             <a:r>
-              <a:rPr lang="en-US" smtClean="0"/>
+              <a:rPr lang="en-US"/>
               <a:t>Click to edit Master title style</a:t>
             </a:r>
-            <a:endParaRPr lang="en-US"/>
           </a:p>
         </p:txBody>
       </p:sp>
@@ -763,38 +772,37 @@
           <a:p>
             <a:pPr lvl="0"/>
             <a:r>
-              <a:rPr lang="en-US" smtClean="0"/>
+              <a:rPr lang="en-US"/>
               <a:t>Click to edit Master text styles</a:t>
             </a:r>
           </a:p>
           <a:p>
             <a:pPr lvl="1"/>
             <a:r>
-              <a:rPr lang="en-US" smtClean="0"/>
+              <a:rPr lang="en-US"/>
               <a:t>Second level</a:t>
             </a:r>
           </a:p>
           <a:p>
             <a:pPr lvl="2"/>
             <a:r>
-              <a:rPr lang="en-US" smtClean="0"/>
+              <a:rPr lang="en-US"/>
               <a:t>Third level</a:t>
             </a:r>
           </a:p>
           <a:p>
             <a:pPr lvl="3"/>
             <a:r>
-              <a:rPr lang="en-US" smtClean="0"/>
+              <a:rPr lang="en-US"/>
               <a:t>Fourth level</a:t>
             </a:r>
           </a:p>
           <a:p>
             <a:pPr lvl="4"/>
             <a:r>
-              <a:rPr lang="en-US" smtClean="0"/>
+              <a:rPr lang="en-US"/>
               <a:t>Fifth level</a:t>
             </a:r>
-            <a:endParaRPr lang="en-US"/>
           </a:p>
         </p:txBody>
       </p:sp>
@@ -815,7 +823,7 @@
           <a:p>
             <a:fld id="{5BCAD085-E8A6-8845-BD4E-CB4CCA059FC4}" type="datetimeFigureOut">
               <a:rPr lang="en-US" smtClean="0"/>
-              <a:t>1/27/13</a:t>
+              <a:t>9/27/2026</a:t>
             </a:fld>
             <a:endParaRPr lang="en-US"/>
           </a:p>
@@ -918,10 +926,9 @@
           </a:lstStyle>
           <a:p>
             <a:r>
-              <a:rPr lang="en-US" smtClean="0"/>
+              <a:rPr lang="en-US"/>
               <a:t>Click to edit Master title style</a:t>
             </a:r>
-            <a:endParaRPr lang="en-US"/>
           </a:p>
         </p:txBody>
       </p:sp>
@@ -1038,7 +1045,7 @@
           <a:p>
             <a:pPr lvl="0"/>
             <a:r>
-              <a:rPr lang="en-US" smtClean="0"/>
+              <a:rPr lang="en-US"/>
               <a:t>Click to edit Master text styles</a:t>
             </a:r>
           </a:p>
@@ -1061,7 +1068,7 @@
           <a:p>
             <a:fld id="{5BCAD085-E8A6-8845-BD4E-CB4CCA059FC4}" type="datetimeFigureOut">
               <a:rPr lang="en-US" smtClean="0"/>
-              <a:t>1/27/13</a:t>
+              <a:t>9/27/2026</a:t>
             </a:fld>
             <a:endParaRPr lang="en-US"/>
           </a:p>
@@ -1155,10 +1162,9 @@
           <a:lstStyle/>
           <a:p>
             <a:r>
-              <a:rPr lang="en-US" smtClean="0"/>
+              <a:rPr lang="en-US"/>
               <a:t>Click to edit Master title style</a:t>
             </a:r>
-            <a:endParaRPr lang="en-US"/>
           </a:p>
         </p:txBody>
       </p:sp>
@@ -1212,38 +1218,37 @@
           <a:p>
             <a:pPr lvl="0"/>
             <a:r>
-              <a:rPr lang="en-US" smtClean="0"/>
+              <a:rPr lang="en-US"/>
               <a:t>Click to edit Master text styles</a:t>
             </a:r>
           </a:p>
           <a:p>
             <a:pPr lvl="1"/>
             <a:r>
-              <a:rPr lang="en-US" smtClean="0"/>
+              <a:rPr lang="en-US"/>
               <a:t>Second level</a:t>
             </a:r>
           </a:p>
           <a:p>
             <a:pPr lvl="2"/>
             <a:r>
-              <a:rPr lang="en-US" smtClean="0"/>
+              <a:rPr lang="en-US"/>
               <a:t>Third level</a:t>
             </a:r>
           </a:p>
           <a:p>
             <a:pPr lvl="3"/>
             <a:r>
-              <a:rPr lang="en-US" smtClean="0"/>
+              <a:rPr lang="en-US"/>
               <a:t>Fourth level</a:t>
             </a:r>
           </a:p>
           <a:p>
             <a:pPr lvl="4"/>
             <a:r>
-              <a:rPr lang="en-US" smtClean="0"/>
+              <a:rPr lang="en-US"/>
               <a:t>Fifth level</a:t>
             </a:r>
-            <a:endParaRPr lang="en-US"/>
           </a:p>
         </p:txBody>
       </p:sp>
@@ -1297,38 +1302,37 @@
           <a:p>
             <a:pPr lvl="0"/>
             <a:r>
-              <a:rPr lang="en-US" smtClean="0"/>
+              <a:rPr lang="en-US"/>
               <a:t>Click to edit Master text styles</a:t>
             </a:r>
           </a:p>
           <a:p>
             <a:pPr lvl="1"/>
             <a:r>
-              <a:rPr lang="en-US" smtClean="0"/>
+              <a:rPr lang="en-US"/>
               <a:t>Second level</a:t>
             </a:r>
           </a:p>
           <a:p>
             <a:pPr lvl="2"/>
             <a:r>
-              <a:rPr lang="en-US" smtClean="0"/>
+              <a:rPr lang="en-US"/>
               <a:t>Third level</a:t>
             </a:r>
           </a:p>
           <a:p>
             <a:pPr lvl="3"/>
             <a:r>
-              <a:rPr lang="en-US" smtClean="0"/>
+              <a:rPr lang="en-US"/>
               <a:t>Fourth level</a:t>
             </a:r>
           </a:p>
           <a:p>
             <a:pPr lvl="4"/>
             <a:r>
-              <a:rPr lang="en-US" smtClean="0"/>
+              <a:rPr lang="en-US"/>
               <a:t>Fifth level</a:t>
             </a:r>
-            <a:endParaRPr lang="en-US"/>
           </a:p>
         </p:txBody>
       </p:sp>
@@ -1349,7 +1353,7 @@
           <a:p>
             <a:fld id="{5BCAD085-E8A6-8845-BD4E-CB4CCA059FC4}" type="datetimeFigureOut">
               <a:rPr lang="en-US" smtClean="0"/>
-              <a:t>1/27/13</a:t>
+              <a:t>9/27/2026</a:t>
             </a:fld>
             <a:endParaRPr lang="en-US"/>
           </a:p>
@@ -1447,10 +1451,9 @@
           </a:lstStyle>
           <a:p>
             <a:r>
-              <a:rPr lang="en-US" smtClean="0"/>
+              <a:rPr lang="en-US"/>
               <a:t>Click to edit Master title style</a:t>
             </a:r>
-            <a:endParaRPr lang="en-US"/>
           </a:p>
         </p:txBody>
       </p:sp>
@@ -1513,7 +1516,7 @@
           <a:p>
             <a:pPr lvl="0"/>
             <a:r>
-              <a:rPr lang="en-US" smtClean="0"/>
+              <a:rPr lang="en-US"/>
               <a:t>Click to edit Master text styles</a:t>
             </a:r>
           </a:p>
@@ -1569,38 +1572,37 @@
           <a:p>
             <a:pPr lvl="0"/>
             <a:r>
-              <a:rPr lang="en-US" smtClean="0"/>
+              <a:rPr lang="en-US"/>
               <a:t>Click to edit Master text styles</a:t>
             </a:r>
           </a:p>
           <a:p>
             <a:pPr lvl="1"/>
             <a:r>
-              <a:rPr lang="en-US" smtClean="0"/>
+              <a:rPr lang="en-US"/>
               <a:t>Second level</a:t>
             </a:r>
           </a:p>
           <a:p>
             <a:pPr lvl="2"/>
             <a:r>
-              <a:rPr lang="en-US" smtClean="0"/>
+              <a:rPr lang="en-US"/>
               <a:t>Third level</a:t>
             </a:r>
           </a:p>
           <a:p>
             <a:pPr lvl="3"/>
             <a:r>
-              <a:rPr lang="en-US" smtClean="0"/>
+              <a:rPr lang="en-US"/>
               <a:t>Fourth level</a:t>
             </a:r>
           </a:p>
           <a:p>
             <a:pPr lvl="4"/>
             <a:r>
-              <a:rPr lang="en-US" smtClean="0"/>
+              <a:rPr lang="en-US"/>
               <a:t>Fifth level</a:t>
             </a:r>
-            <a:endParaRPr lang="en-US"/>
           </a:p>
         </p:txBody>
       </p:sp>
@@ -1663,7 +1665,7 @@
           <a:p>
             <a:pPr lvl="0"/>
             <a:r>
-              <a:rPr lang="en-US" smtClean="0"/>
+              <a:rPr lang="en-US"/>
               <a:t>Click to edit Master text styles</a:t>
             </a:r>
           </a:p>
@@ -1719,38 +1721,37 @@
           <a:p>
             <a:pPr lvl="0"/>
             <a:r>
-              <a:rPr lang="en-US" smtClean="0"/>
+              <a:rPr lang="en-US"/>
               <a:t>Click to edit Master text styles</a:t>
             </a:r>
           </a:p>
           <a:p>
             <a:pPr lvl="1"/>
             <a:r>
-              <a:rPr lang="en-US" smtClean="0"/>
+              <a:rPr lang="en-US"/>
               <a:t>Second level</a:t>
             </a:r>
           </a:p>
           <a:p>
             <a:pPr lvl="2"/>
             <a:r>
-              <a:rPr lang="en-US" smtClean="0"/>
+              <a:rPr lang="en-US"/>
               <a:t>Third level</a:t>
             </a:r>
           </a:p>
           <a:p>
             <a:pPr lvl="3"/>
             <a:r>
-              <a:rPr lang="en-US" smtClean="0"/>
+              <a:rPr lang="en-US"/>
               <a:t>Fourth level</a:t>
             </a:r>
           </a:p>
           <a:p>
             <a:pPr lvl="4"/>
             <a:r>
-              <a:rPr lang="en-US" smtClean="0"/>
+              <a:rPr lang="en-US"/>
               <a:t>Fifth level</a:t>
             </a:r>
-            <a:endParaRPr lang="en-US"/>
           </a:p>
         </p:txBody>
       </p:sp>
@@ -1771,7 +1772,7 @@
           <a:p>
             <a:fld id="{5BCAD085-E8A6-8845-BD4E-CB4CCA059FC4}" type="datetimeFigureOut">
               <a:rPr lang="en-US" smtClean="0"/>
-              <a:t>1/27/13</a:t>
+              <a:t>9/27/2026</a:t>
             </a:fld>
             <a:endParaRPr lang="en-US"/>
           </a:p>
@@ -1865,10 +1866,9 @@
           <a:lstStyle/>
           <a:p>
             <a:r>
-              <a:rPr lang="en-US" smtClean="0"/>
+              <a:rPr lang="en-US"/>
               <a:t>Click to edit Master title style</a:t>
             </a:r>
-            <a:endParaRPr lang="en-US"/>
           </a:p>
         </p:txBody>
       </p:sp>
@@ -1889,7 +1889,7 @@
           <a:p>
             <a:fld id="{5BCAD085-E8A6-8845-BD4E-CB4CCA059FC4}" type="datetimeFigureOut">
               <a:rPr lang="en-US" smtClean="0"/>
-              <a:t>1/27/13</a:t>
+              <a:t>9/27/2026</a:t>
             </a:fld>
             <a:endParaRPr lang="en-US"/>
           </a:p>
@@ -1984,7 +1984,7 @@
           <a:p>
             <a:fld id="{5BCAD085-E8A6-8845-BD4E-CB4CCA059FC4}" type="datetimeFigureOut">
               <a:rPr lang="en-US" smtClean="0"/>
-              <a:t>1/27/13</a:t>
+              <a:t>9/27/2026</a:t>
             </a:fld>
             <a:endParaRPr lang="en-US"/>
           </a:p>
@@ -2087,10 +2087,9 @@
           </a:lstStyle>
           <a:p>
             <a:r>
-              <a:rPr lang="en-US" smtClean="0"/>
+              <a:rPr lang="en-US"/>
               <a:t>Click to edit Master title style</a:t>
             </a:r>
-            <a:endParaRPr lang="en-US"/>
           </a:p>
         </p:txBody>
       </p:sp>
@@ -2144,38 +2143,37 @@
           <a:p>
             <a:pPr lvl="0"/>
             <a:r>
-              <a:rPr lang="en-US" smtClean="0"/>
+              <a:rPr lang="en-US"/>
               <a:t>Click to edit Master text styles</a:t>
             </a:r>
           </a:p>
           <a:p>
             <a:pPr lvl="1"/>
             <a:r>
-              <a:rPr lang="en-US" smtClean="0"/>
+              <a:rPr lang="en-US"/>
               <a:t>Second level</a:t>
             </a:r>
           </a:p>
           <a:p>
             <a:pPr lvl="2"/>
             <a:r>
-              <a:rPr lang="en-US" smtClean="0"/>
+              <a:rPr lang="en-US"/>
               <a:t>Third level</a:t>
             </a:r>
           </a:p>
           <a:p>
             <a:pPr lvl="3"/>
             <a:r>
-              <a:rPr lang="en-US" smtClean="0"/>
+              <a:rPr lang="en-US"/>
               <a:t>Fourth level</a:t>
             </a:r>
           </a:p>
           <a:p>
             <a:pPr lvl="4"/>
             <a:r>
-              <a:rPr lang="en-US" smtClean="0"/>
+              <a:rPr lang="en-US"/>
               <a:t>Fifth level</a:t>
             </a:r>
-            <a:endParaRPr lang="en-US"/>
           </a:p>
         </p:txBody>
       </p:sp>
@@ -2238,7 +2236,7 @@
           <a:p>
             <a:pPr lvl="0"/>
             <a:r>
-              <a:rPr lang="en-US" smtClean="0"/>
+              <a:rPr lang="en-US"/>
               <a:t>Click to edit Master text styles</a:t>
             </a:r>
           </a:p>
@@ -2261,7 +2259,7 @@
           <a:p>
             <a:fld id="{5BCAD085-E8A6-8845-BD4E-CB4CCA059FC4}" type="datetimeFigureOut">
               <a:rPr lang="en-US" smtClean="0"/>
-              <a:t>1/27/13</a:t>
+              <a:t>9/27/2026</a:t>
             </a:fld>
             <a:endParaRPr lang="en-US"/>
           </a:p>
@@ -2364,10 +2362,9 @@
           </a:lstStyle>
           <a:p>
             <a:r>
-              <a:rPr lang="en-US" smtClean="0"/>
+              <a:rPr lang="en-US"/>
               <a:t>Click to edit Master title style</a:t>
             </a:r>
-            <a:endParaRPr lang="en-US"/>
           </a:p>
         </p:txBody>
       </p:sp>
@@ -2491,7 +2488,7 @@
           <a:p>
             <a:pPr lvl="0"/>
             <a:r>
-              <a:rPr lang="en-US" smtClean="0"/>
+              <a:rPr lang="en-US"/>
               <a:t>Click to edit Master text styles</a:t>
             </a:r>
           </a:p>
@@ -2514,7 +2511,7 @@
           <a:p>
             <a:fld id="{5BCAD085-E8A6-8845-BD4E-CB4CCA059FC4}" type="datetimeFigureOut">
               <a:rPr lang="en-US" smtClean="0"/>
-              <a:t>1/27/13</a:t>
+              <a:t>9/27/2026</a:t>
             </a:fld>
             <a:endParaRPr lang="en-US"/>
           </a:p>
@@ -2623,10 +2620,9 @@
           <a:lstStyle/>
           <a:p>
             <a:r>
-              <a:rPr lang="en-US" smtClean="0"/>
+              <a:rPr lang="en-US"/>
               <a:t>Click to edit Master title style</a:t>
             </a:r>
-            <a:endParaRPr lang="en-US"/>
           </a:p>
         </p:txBody>
       </p:sp>
@@ -2657,38 +2653,37 @@
           <a:p>
             <a:pPr lvl="0"/>
             <a:r>
-              <a:rPr lang="en-US" smtClean="0"/>
+              <a:rPr lang="en-US"/>
               <a:t>Click to edit Master text styles</a:t>
             </a:r>
           </a:p>
           <a:p>
             <a:pPr lvl="1"/>
             <a:r>
-              <a:rPr lang="en-US" smtClean="0"/>
+              <a:rPr lang="en-US"/>
               <a:t>Second level</a:t>
             </a:r>
           </a:p>
           <a:p>
             <a:pPr lvl="2"/>
             <a:r>
-              <a:rPr lang="en-US" smtClean="0"/>
+              <a:rPr lang="en-US"/>
               <a:t>Third level</a:t>
             </a:r>
           </a:p>
           <a:p>
             <a:pPr lvl="3"/>
             <a:r>
-              <a:rPr lang="en-US" smtClean="0"/>
+              <a:rPr lang="en-US"/>
               <a:t>Fourth level</a:t>
             </a:r>
           </a:p>
           <a:p>
             <a:pPr lvl="4"/>
             <a:r>
-              <a:rPr lang="en-US" smtClean="0"/>
+              <a:rPr lang="en-US"/>
               <a:t>Fifth level</a:t>
             </a:r>
-            <a:endParaRPr lang="en-US"/>
           </a:p>
         </p:txBody>
       </p:sp>
@@ -2727,7 +2722,7 @@
           <a:p>
             <a:fld id="{5BCAD085-E8A6-8845-BD4E-CB4CCA059FC4}" type="datetimeFigureOut">
               <a:rPr lang="en-US" smtClean="0"/>
-              <a:t>1/27/13</a:t>
+              <a:t>9/27/2026</a:t>
             </a:fld>
             <a:endParaRPr lang="en-US"/>
           </a:p>
@@ -3086,7 +3081,7 @@
 </file>
 
 <file path=ppt/slides/slide1.xml><?xml version="1.0" encoding="utf-8"?>
-<p:sld xmlns:a="http://schemas.openxmlformats.org/drawingml/2006/main" xmlns:p="http://schemas.openxmlformats.org/presentationml/2006/main" xmlns:r="http://schemas.openxmlformats.org/officeDocument/2006/relationships">
+<p:sld xmlns:a="http://schemas.openxmlformats.org/drawingml/2006/main" xmlns:r="http://schemas.openxmlformats.org/officeDocument/2006/relationships" xmlns:p="http://schemas.openxmlformats.org/presentationml/2006/main">
   <p:cSld>
     <p:spTree>
       <p:nvGrpSpPr>
@@ -3094,7 +3089,14 @@
         <p:cNvGrpSpPr/>
         <p:nvPr/>
       </p:nvGrpSpPr>
-      <p:grpSpPr/>
+      <p:grpSpPr>
+        <a:xfrm>
+          <a:off x="0" y="0"/>
+          <a:ext cx="0" cy="0"/>
+          <a:chOff x="0" y="0"/>
+          <a:chExt cx="0" cy="0"/>
+        </a:xfrm>
+      </p:grpSpPr>
       <p:sp>
         <p:nvSpPr>
           <p:cNvPr id="2" name="Rectangle 1"/>
@@ -3135,6 +3137,7 @@
           <a:lstStyle/>
           <a:p>
             <a:pPr algn="ctr"/>
+            <a:endParaRPr/>
           </a:p>
         </p:txBody>
       </p:sp>
@@ -3147,7 +3150,7 @@
         <p:spPr>
           <a:xfrm>
             <a:off x="1097280" y="1645920"/>
-            <a:ext cx="10058400" cy="4114800"/>
+            <a:ext cx="10058400" cy="2508379"/>
           </a:xfrm>
           <a:prstGeom prst="rect">
             <a:avLst/>
@@ -3171,6 +3174,7 @@
               </a:defRPr>
             </a:pPr>
             <a:r>
+              <a:rPr dirty="0"/>
               <a:t>Student Grade Calculator</a:t>
             </a:r>
           </a:p>
@@ -3186,6 +3190,7 @@
               </a:defRPr>
             </a:pPr>
             <a:r>
+              <a:rPr dirty="0"/>
               <a:t>Interactive JavaScript &amp; ReactJS Application Development</a:t>
             </a:r>
           </a:p>
@@ -3201,6 +3206,7 @@
               </a:defRPr>
             </a:pPr>
             <a:r>
+              <a:rPr dirty="0"/>
               <a:t>Problem Statement: "Enter marks, calculate total and average, assign grades, and display results."</a:t>
             </a:r>
           </a:p>
@@ -3213,10 +3219,22 @@
               </a:defRPr>
             </a:pPr>
             <a:r>
-              <a:t>Course: Full Stack Web Development  |  Class: III CSE — F Section</a:t>
-            </a:r>
-            <a:br/>
-            <a:r>
+              <a:rPr dirty="0"/>
+              <a:t>Course: Full Stack Web Development  |  Class: III CSE — </a:t>
+            </a:r>
+            <a:r>
+              <a:rPr lang="en-US" dirty="0"/>
+              <a:t>C</a:t>
+            </a:r>
+            <a:r>
+              <a:rPr dirty="0"/>
+              <a:t> Section</a:t>
+            </a:r>
+            <a:br>
+              <a:rPr dirty="0"/>
+            </a:br>
+            <a:r>
+              <a:rPr dirty="0"/>
               <a:t>Submission for Task 2 Self-Learning Evaluation</a:t>
             </a:r>
           </a:p>
@@ -3231,7 +3249,7 @@
 </file>
 
 <file path=ppt/slides/slide2.xml><?xml version="1.0" encoding="utf-8"?>
-<p:sld xmlns:a="http://schemas.openxmlformats.org/drawingml/2006/main" xmlns:p="http://schemas.openxmlformats.org/presentationml/2006/main" xmlns:r="http://schemas.openxmlformats.org/officeDocument/2006/relationships">
+<p:sld xmlns:a="http://schemas.openxmlformats.org/drawingml/2006/main" xmlns:r="http://schemas.openxmlformats.org/officeDocument/2006/relationships" xmlns:p="http://schemas.openxmlformats.org/presentationml/2006/main">
   <p:cSld>
     <p:spTree>
       <p:nvGrpSpPr>
@@ -3239,7 +3257,14 @@
         <p:cNvGrpSpPr/>
         <p:nvPr/>
       </p:nvGrpSpPr>
-      <p:grpSpPr/>
+      <p:grpSpPr>
+        <a:xfrm>
+          <a:off x="0" y="0"/>
+          <a:ext cx="0" cy="0"/>
+          <a:chOff x="0" y="0"/>
+          <a:chExt cx="0" cy="0"/>
+        </a:xfrm>
+      </p:grpSpPr>
       <p:sp>
         <p:nvSpPr>
           <p:cNvPr id="2" name="TextBox 1"/>
@@ -3592,7 +3617,7 @@
 </file>
 
 <file path=ppt/slides/slide3.xml><?xml version="1.0" encoding="utf-8"?>
-<p:sld xmlns:a="http://schemas.openxmlformats.org/drawingml/2006/main" xmlns:p="http://schemas.openxmlformats.org/presentationml/2006/main" xmlns:r="http://schemas.openxmlformats.org/officeDocument/2006/relationships">
+<p:sld xmlns:a="http://schemas.openxmlformats.org/drawingml/2006/main" xmlns:r="http://schemas.openxmlformats.org/officeDocument/2006/relationships" xmlns:p="http://schemas.openxmlformats.org/presentationml/2006/main">
   <p:cSld>
     <p:spTree>
       <p:nvGrpSpPr>
@@ -3600,7 +3625,14 @@
         <p:cNvGrpSpPr/>
         <p:nvPr/>
       </p:nvGrpSpPr>
-      <p:grpSpPr/>
+      <p:grpSpPr>
+        <a:xfrm>
+          <a:off x="0" y="0"/>
+          <a:ext cx="0" cy="0"/>
+          <a:chOff x="0" y="0"/>
+          <a:chExt cx="0" cy="0"/>
+        </a:xfrm>
+      </p:grpSpPr>
       <p:sp>
         <p:nvSpPr>
           <p:cNvPr id="2" name="TextBox 1"/>
@@ -4093,7 +4125,7 @@
 </file>
 
 <file path=ppt/slides/slide4.xml><?xml version="1.0" encoding="utf-8"?>
-<p:sld xmlns:a="http://schemas.openxmlformats.org/drawingml/2006/main" xmlns:p="http://schemas.openxmlformats.org/presentationml/2006/main" xmlns:r="http://schemas.openxmlformats.org/officeDocument/2006/relationships">
+<p:sld xmlns:a="http://schemas.openxmlformats.org/drawingml/2006/main" xmlns:r="http://schemas.openxmlformats.org/officeDocument/2006/relationships" xmlns:p="http://schemas.openxmlformats.org/presentationml/2006/main">
   <p:cSld>
     <p:spTree>
       <p:nvGrpSpPr>
@@ -4101,7 +4133,14 @@
         <p:cNvGrpSpPr/>
         <p:nvPr/>
       </p:nvGrpSpPr>
-      <p:grpSpPr/>
+      <p:grpSpPr>
+        <a:xfrm>
+          <a:off x="0" y="0"/>
+          <a:ext cx="0" cy="0"/>
+          <a:chOff x="0" y="0"/>
+          <a:chExt cx="0" cy="0"/>
+        </a:xfrm>
+      </p:grpSpPr>
       <p:sp>
         <p:nvSpPr>
           <p:cNvPr id="2" name="TextBox 1"/>
@@ -4526,13 +4565,6 @@
           </a:p>
           <a:p>
             <a:br/>
-            <a:pPr>
-              <a:defRPr sz="1050" i="1">
-                <a:solidFill>
-                  <a:srgbClr val="B91C1C"/>
-                </a:solidFill>
-              </a:defRPr>
-            </a:pPr>
             <a:r>
               <a:t>* Passing Condition: A student must score ≥ 50 marks in each individual subject to pass. Scoring &lt; 50 in even one subject marks the student as 'Fail'.</a:t>
             </a:r>
@@ -4548,7 +4580,7 @@
 </file>
 
 <file path=ppt/slides/slide5.xml><?xml version="1.0" encoding="utf-8"?>
-<p:sld xmlns:a="http://schemas.openxmlformats.org/drawingml/2006/main" xmlns:p="http://schemas.openxmlformats.org/presentationml/2006/main" xmlns:r="http://schemas.openxmlformats.org/officeDocument/2006/relationships">
+<p:sld xmlns:a="http://schemas.openxmlformats.org/drawingml/2006/main" xmlns:r="http://schemas.openxmlformats.org/officeDocument/2006/relationships" xmlns:p="http://schemas.openxmlformats.org/presentationml/2006/main">
   <p:cSld>
     <p:spTree>
       <p:nvGrpSpPr>
@@ -4556,7 +4588,14 @@
         <p:cNvGrpSpPr/>
         <p:nvPr/>
       </p:nvGrpSpPr>
-      <p:grpSpPr/>
+      <p:grpSpPr>
+        <a:xfrm>
+          <a:off x="0" y="0"/>
+          <a:ext cx="0" cy="0"/>
+          <a:chOff x="0" y="0"/>
+          <a:chExt cx="0" cy="0"/>
+        </a:xfrm>
+      </p:grpSpPr>
       <p:sp>
         <p:nvSpPr>
           <p:cNvPr id="2" name="TextBox 1"/>
@@ -4939,7 +4978,7 @@
 </file>
 
 <file path=ppt/slides/slide6.xml><?xml version="1.0" encoding="utf-8"?>
-<p:sld xmlns:a="http://schemas.openxmlformats.org/drawingml/2006/main" xmlns:p="http://schemas.openxmlformats.org/presentationml/2006/main" xmlns:r="http://schemas.openxmlformats.org/officeDocument/2006/relationships">
+<p:sld xmlns:a="http://schemas.openxmlformats.org/drawingml/2006/main" xmlns:r="http://schemas.openxmlformats.org/officeDocument/2006/relationships" xmlns:p="http://schemas.openxmlformats.org/presentationml/2006/main">
   <p:cSld>
     <p:spTree>
       <p:nvGrpSpPr>
@@ -4947,7 +4986,14 @@
         <p:cNvGrpSpPr/>
         <p:nvPr/>
       </p:nvGrpSpPr>
-      <p:grpSpPr/>
+      <p:grpSpPr>
+        <a:xfrm>
+          <a:off x="0" y="0"/>
+          <a:ext cx="0" cy="0"/>
+          <a:chOff x="0" y="0"/>
+          <a:chExt cx="0" cy="0"/>
+        </a:xfrm>
+      </p:grpSpPr>
       <p:sp>
         <p:nvSpPr>
           <p:cNvPr id="2" name="TextBox 1"/>
@@ -5028,7 +5074,7 @@
 </file>
 
 <file path=ppt/slides/slide7.xml><?xml version="1.0" encoding="utf-8"?>
-<p:sld xmlns:a="http://schemas.openxmlformats.org/drawingml/2006/main" xmlns:p="http://schemas.openxmlformats.org/presentationml/2006/main" xmlns:r="http://schemas.openxmlformats.org/officeDocument/2006/relationships">
+<p:sld xmlns:a="http://schemas.openxmlformats.org/drawingml/2006/main" xmlns:r="http://schemas.openxmlformats.org/officeDocument/2006/relationships" xmlns:p="http://schemas.openxmlformats.org/presentationml/2006/main">
   <p:cSld>
     <p:spTree>
       <p:nvGrpSpPr>
@@ -5036,7 +5082,14 @@
         <p:cNvGrpSpPr/>
         <p:nvPr/>
       </p:nvGrpSpPr>
-      <p:grpSpPr/>
+      <p:grpSpPr>
+        <a:xfrm>
+          <a:off x="0" y="0"/>
+          <a:ext cx="0" cy="0"/>
+          <a:chOff x="0" y="0"/>
+          <a:chExt cx="0" cy="0"/>
+        </a:xfrm>
+      </p:grpSpPr>
       <p:sp>
         <p:nvSpPr>
           <p:cNvPr id="2" name="TextBox 1"/>
@@ -5117,7 +5170,7 @@
 </file>
 
 <file path=ppt/slides/slide8.xml><?xml version="1.0" encoding="utf-8"?>
-<p:sld xmlns:a="http://schemas.openxmlformats.org/drawingml/2006/main" xmlns:p="http://schemas.openxmlformats.org/presentationml/2006/main" xmlns:r="http://schemas.openxmlformats.org/officeDocument/2006/relationships">
+<p:sld xmlns:a="http://schemas.openxmlformats.org/drawingml/2006/main" xmlns:r="http://schemas.openxmlformats.org/officeDocument/2006/relationships" xmlns:p="http://schemas.openxmlformats.org/presentationml/2006/main">
   <p:cSld>
     <p:spTree>
       <p:nvGrpSpPr>
@@ -5125,7 +5178,14 @@
         <p:cNvGrpSpPr/>
         <p:nvPr/>
       </p:nvGrpSpPr>
-      <p:grpSpPr/>
+      <p:grpSpPr>
+        <a:xfrm>
+          <a:off x="0" y="0"/>
+          <a:ext cx="0" cy="0"/>
+          <a:chOff x="0" y="0"/>
+          <a:chExt cx="0" cy="0"/>
+        </a:xfrm>
+      </p:grpSpPr>
       <p:sp>
         <p:nvSpPr>
           <p:cNvPr id="2" name="TextBox 1"/>

</xml_diff>